<commit_message>
docs(slide): regenerate deck with guardrail terminology + layout tweaks
Replaces 「強制統制」 with 「ガードレール」 throughout the Agent Skills x
Governance deck (16 occurrences across slide copy + speaker notes).
Also incorporates the hook lifecycle layout, harness engineering
reflection slide, and directory-tree tuning accumulated since the
initial 18-slide deck.

Co-Authored-By: Claude Opus 4.7 (1M context) <noreply@anthropic.com>
</commit_message>
<xml_diff>
--- a/docs/slide/agent_skills_slides_jp.pptx
+++ b/docs/slide/agent_skills_slides_jp.pptx
@@ -556,7 +556,7 @@
           </a:p>
           <a:p>
             <a:r>
-              <a:t>  ・AI 支援と強制統制は、同じ仕組みに背負わせないという立場を最初に示す。</a:t>
+              <a:t>  ・AI 支援とガードレールは、同じ仕組みに背負わせないという立場を最初に示す。</a:t>
             </a:r>
           </a:p>
           <a:p/>
@@ -768,7 +768,7 @@
           <a:p/>
           <a:p>
             <a:r>
-              <a:t>【次ページへのつなぎ】この外側に、GitHub / CI の強制統制を配置する。</a:t>
+              <a:t>【次ページへのつなぎ】この外側に、GitHub / CI のガードレールを配置する。</a:t>
             </a:r>
           </a:p>
         </p:txBody>
@@ -1065,7 +1065,7 @@
           </a:p>
           <a:p>
             <a:r>
-              <a:t>  2. Step 5-6 は強制統制（wine）、Step 7 は人の承認（orange）と色で責務を分ける。</a:t>
+              <a:t>  2. Step 5-6 はガードレール（wine）、Step 7 は人の承認（orange）と色で責務を分ける。</a:t>
             </a:r>
           </a:p>
           <a:p/>
@@ -1735,7 +1735,7 @@
           </a:p>
           <a:p>
             <a:r>
-              <a:t>  ・問題を 3 つに束ねることで、後段の責務分離（AI支援 vs 強制統制）に綺麗につながる。</a:t>
+              <a:t>  ・問題を 3 つに束ねることで、後段の責務分離（AI支援 vs ガードレール）に綺麗につながる。</a:t>
             </a:r>
           </a:p>
           <a:p/>
@@ -2038,7 +2038,7 @@
           </a:p>
           <a:p>
             <a:r>
-              <a:t>  3. merge / deploy / secret の最終遮断は hooks の責務ではない。次のスライドで GitHub / CI 側の強制統制に持たせる。</a:t>
+              <a:t>  3. merge / deploy / secret の最終遮断は hooks の責務ではない。次のスライドで GitHub / CI 側のガードレールに持たせる。</a:t>
             </a:r>
           </a:p>
           <a:p/>
@@ -2055,7 +2055,7 @@
           <a:p/>
           <a:p>
             <a:r>
-              <a:t>【次ページへのつなぎ】ここまでで AI の挙動は整う。では保護境界は ―― 次に GitHub / CI の強制統制を見る。</a:t>
+              <a:t>【次ページへのつなぎ】ここまでで AI の挙動は整う。では保護境界は ―― 次に GitHub / CI のガードレールを見る。</a:t>
             </a:r>
           </a:p>
         </p:txBody>
@@ -2157,7 +2157,7 @@
           </a:p>
           <a:p>
             <a:r>
-              <a:t>  ・このレイヤーの本質は、強制統制・監査可能性・承認境界の明確化。</a:t>
+              <a:t>  ・このレイヤーの本質は、ガードレール・監査可能性・承認境界の明確化。</a:t>
             </a:r>
           </a:p>
           <a:p/>
@@ -2249,7 +2249,7 @@
           </a:p>
           <a:p>
             <a:r>
-              <a:t>  2. Layer 1-2 は AI 支援、Layer 3-4 は強制統制という色分けで以降のスライドを読む。</a:t>
+              <a:t>  2. Layer 1-2 は AI 支援、Layer 3-4 はガードレールという色分けで以降のスライドを読む。</a:t>
             </a:r>
           </a:p>
           <a:p/>
@@ -2347,7 +2347,7 @@
           </a:p>
           <a:p>
             <a:r>
-              <a:t>  1. AI 支援レイヤーは「よりよく作業させる」ため。強制統制レイヤーは「通してよい結果だけを通す」ため。</a:t>
+              <a:t>  1. AI 支援レイヤーは「よりよく作業させる」ため。一方ガードレールは「通してよい結果だけを通す」ため。</a:t>
             </a:r>
           </a:p>
           <a:p>
@@ -5522,7 +5522,7 @@
                 <a:ea typeface="Yu Gothic UI"/>
                 <a:cs typeface="Yu Gothic UI"/>
               </a:rPr>
-              <a:t>AI 支援と強制統制は分けて設計する</a:t>
+              <a:t>AI 支援とガードレールは分けて設計する</a:t>
             </a:r>
           </a:p>
         </p:txBody>
@@ -5914,7 +5914,7 @@
                 <a:ea typeface="Yu Gothic UI"/>
                 <a:cs typeface="Yu Gothic UI"/>
               </a:rPr>
-              <a:t>強制統制</a:t>
+              <a:t>ガードレール</a:t>
             </a:r>
           </a:p>
         </p:txBody>
@@ -25231,7 +25231,7 @@
                 <a:ea typeface="Yu Gothic UI"/>
                 <a:cs typeface="Yu Gothic UI"/>
               </a:rPr>
-              <a:t>役割は「実行中の挙動調整」であり、「最終的な強制統制」ではありません。</a:t>
+              <a:t>役割は「実行中の挙動調整」であり、「最終的なガードレール」ではありません。</a:t>
             </a:r>
           </a:p>
         </p:txBody>
@@ -30036,7 +30036,7 @@
                 <a:ea typeface="Yu Gothic UI"/>
                 <a:cs typeface="Yu Gothic UI"/>
               </a:rPr>
-              <a:t>secret / deploy は強制統制で守れる</a:t>
+              <a:t>secret / deploy はガードレールで守れる</a:t>
             </a:r>
           </a:p>
         </p:txBody>
@@ -30352,7 +30352,7 @@
                 <a:ea typeface="Yu Gothic UI"/>
                 <a:cs typeface="Yu Gothic UI"/>
               </a:rPr>
-              <a:t>設計原則 ― AI 支援と強制統制を分ける</a:t>
+              <a:t>設計原則 ― AI 支援とガードレールを分ける</a:t>
             </a:r>
           </a:p>
         </p:txBody>
@@ -31079,7 +31079,7 @@
                 <a:ea typeface="Yu Gothic UI"/>
                 <a:cs typeface="Yu Gothic UI"/>
               </a:rPr>
-              <a:t>強制統制</a:t>
+              <a:t>ガードレール</a:t>
             </a:r>
           </a:p>
         </p:txBody>

</xml_diff>